<commit_message>
Rename section 精选研报 -> 精选观点; web: bulk delete mode, triple confirmation for clearing all materials
Co-Authored-By: Claude Opus 5 <noreply@anthropic.com>
</commit_message>
<xml_diff>
--- a/jin10-server/templates/plus_daily_source.pptx
+++ b/jin10-server/templates/plus_daily_source.pptx
@@ -475,7 +475,7 @@
             </a:r>
             <a:r>
               <a:rPr lang="zh-CN" altLang="en-US"/>
-              <a:t>外汇热点、精选图示、精选研报</a:t>
+              <a:t>外汇热点、精选图示、精选观点</a:t>
             </a:r>
             <a:endParaRPr lang="zh-CN" altLang="en-US"/>
           </a:p>
@@ -2872,7 +2872,7 @@
                 <a:ea typeface="思源黑体 CN Light" panose="020B0300000000000000" pitchFamily="34" charset="-128"/>
                 <a:sym typeface="+mn-ea"/>
               </a:rPr>
-              <a:t>精选研报</a:t>
+              <a:t>精选观点</a:t>
             </a:r>
             <a:endParaRPr lang="zh-CN" altLang="en-US" sz="3200" dirty="0">
               <a:latin typeface="思源黑体 CN Light" panose="020B0300000000000000" pitchFamily="34" charset="-128"/>
@@ -9183,7 +9183,7 @@
                 <a:rPr lang="zh-CN" altLang="en-US" sz="5400">
                   <a:sym typeface="+mn-ea"/>
                 </a:rPr>
-                <a:t>精选研报</a:t>
+                <a:t>精选观点</a:t>
               </a:r>
               <a:endParaRPr lang="zh-CN" altLang="en-US" sz="5400" b="1">
                 <a:solidFill>

</xml_diff>